<commit_message>
Rename slides from 'Pact3D' to 'Tracking' to match Shirley's deck
https://claude.ai/code/session_01XXtVFWDWgvnnc8uXSWXQhz
</commit_message>
<xml_diff>
--- a/Pact3D_Presentation.pptx
+++ b/Pact3D_Presentation.pptx
@@ -3146,7 +3146,7 @@
               </a:defRPr>
             </a:pPr>
             <a:r>
-              <a:t>Pact3D</a:t>
+              <a:t>Tracking</a:t>
             </a:r>
           </a:p>
         </p:txBody>
@@ -3185,7 +3185,7 @@
               </a:defRPr>
             </a:pPr>
             <a:r>
-              <a:t>Physics-Aware Contact Tracking in 3D</a:t>
+              <a:t>3D Human Pose/Motion Tracking</a:t>
             </a:r>
           </a:p>
         </p:txBody>
@@ -3303,7 +3303,7 @@
               </a:defRPr>
             </a:pPr>
             <a:r>
-              <a:t>Pact3D</a:t>
+              <a:t>Tracking</a:t>
             </a:r>
           </a:p>
         </p:txBody>
@@ -3887,7 +3887,7 @@
               </a:defRPr>
             </a:pPr>
             <a:r>
-              <a:t>Pact3D</a:t>
+              <a:t>Tracking</a:t>
             </a:r>
           </a:p>
         </p:txBody>
@@ -5436,7 +5436,7 @@
               </a:defRPr>
             </a:pPr>
             <a:r>
-              <a:t>Pact3D</a:t>
+              <a:t>Tracking</a:t>
             </a:r>
           </a:p>
         </p:txBody>
@@ -6935,7 +6935,7 @@
               </a:defRPr>
             </a:pPr>
             <a:r>
-              <a:t>Pact3D</a:t>
+              <a:t>Tracking</a:t>
             </a:r>
           </a:p>
         </p:txBody>
@@ -7939,7 +7939,7 @@
               </a:defRPr>
             </a:pPr>
             <a:r>
-              <a:t>Pact3D</a:t>
+              <a:t>Tracking</a:t>
             </a:r>
           </a:p>
         </p:txBody>
@@ -8854,7 +8854,7 @@
               </a:defRPr>
             </a:pPr>
             <a:r>
-              <a:t>Pact3D</a:t>
+              <a:t>Tracking</a:t>
             </a:r>
           </a:p>
         </p:txBody>
@@ -10433,7 +10433,7 @@
               </a:defRPr>
             </a:pPr>
             <a:r>
-              <a:t>Pact3D</a:t>
+              <a:t>Tracking</a:t>
             </a:r>
           </a:p>
         </p:txBody>
@@ -11273,7 +11273,7 @@
               </a:defRPr>
             </a:pPr>
             <a:r>
-              <a:t>Pact3D</a:t>
+              <a:t>Tracking</a:t>
             </a:r>
           </a:p>
         </p:txBody>
@@ -12324,7 +12324,7 @@
               </a:defRPr>
             </a:pPr>
             <a:r>
-              <a:t>Pact3D: combine Human3R + DA3 + physics layer</a:t>
+              <a:t>Combine Human3R + DA3 + physics layer</a:t>
             </a:r>
           </a:p>
           <a:p>
@@ -12480,7 +12480,7 @@
               </a:defRPr>
             </a:pPr>
             <a:r>
-              <a:t>Pact3D</a:t>
+              <a:t>Tracking</a:t>
             </a:r>
           </a:p>
         </p:txBody>
@@ -12818,7 +12818,7 @@
               </a:defRPr>
             </a:pPr>
             <a:r>
-              <a:t>→  Pact3D sits here: physics-aware joint human-scene tracking</a:t>
+              <a:t>→  Our focus: physics-aware joint human-scene tracking</a:t>
             </a:r>
           </a:p>
         </p:txBody>
@@ -12936,7 +12936,7 @@
               </a:defRPr>
             </a:pPr>
             <a:r>
-              <a:t>Pact3D</a:t>
+              <a:t>Tracking</a:t>
             </a:r>
           </a:p>
         </p:txBody>
@@ -14059,7 +14059,7 @@
               </a:defRPr>
             </a:pPr>
             <a:r>
-              <a:t>Pact3D</a:t>
+              <a:t>Tracking</a:t>
             </a:r>
           </a:p>
         </p:txBody>
@@ -14375,7 +14375,7 @@
               </a:defRPr>
             </a:pPr>
             <a:r>
-              <a:t>Pact3D = body tracker + scene geometry</a:t>
+              <a:t>Approach = body tracker + scene geometry</a:t>
             </a:r>
           </a:p>
           <a:p>
@@ -14575,7 +14575,7 @@
               </a:defRPr>
             </a:pPr>
             <a:r>
-              <a:t>Pact3D</a:t>
+              <a:t>Tracking</a:t>
             </a:r>
           </a:p>
         </p:txBody>
@@ -15457,7 +15457,7 @@
               </a:defRPr>
             </a:pPr>
             <a:r>
-              <a:t>Pact3D</a:t>
+              <a:t>Tracking</a:t>
             </a:r>
           </a:p>
         </p:txBody>
@@ -16051,7 +16051,7 @@
               </a:defRPr>
             </a:pPr>
             <a:r>
-              <a:t>Pact3D</a:t>
+              <a:t>Tracking</a:t>
             </a:r>
           </a:p>
         </p:txBody>
@@ -16496,7 +16496,7 @@
               </a:defRPr>
             </a:pPr>
             <a:r>
-              <a:t>Pact3D</a:t>
+              <a:t>Tracking</a:t>
             </a:r>
           </a:p>
         </p:txBody>
@@ -17001,7 +17001,7 @@
               </a:defRPr>
             </a:pPr>
             <a:r>
-              <a:t>Pact3D</a:t>
+              <a:t>Tracking</a:t>
             </a:r>
           </a:p>
         </p:txBody>

</xml_diff>